<commit_message>
updates script and slides
</commit_message>
<xml_diff>
--- a/A Brief Intro To GMAT - Phasing Maneuver Example.pptx
+++ b/A Brief Intro To GMAT - Phasing Maneuver Example.pptx
@@ -111,6 +111,11 @@
       </a:defRPr>
     </a:lvl9pPr>
   </p:defaultTextStyle>
+  <p:extLst>
+    <p:ext uri="{EFAFB233-063F-42B5-8137-9DF3F51BA10A}">
+      <p15:sldGuideLst xmlns:p15="http://schemas.microsoft.com/office/powerpoint/2012/main"/>
+    </p:ext>
+  </p:extLst>
 </p:presentation>
 </file>
 
@@ -196,7 +201,7 @@
           <a:p>
             <a:fld id="{1A91D20D-C4E2-4D60-A335-1BEC39CE9D3B}" type="datetimeFigureOut">
               <a:rPr lang="en-US" smtClean="0"/>
-              <a:t>5/12/2026</a:t>
+              <a:t>5/13/2026</a:t>
             </a:fld>
             <a:endParaRPr lang="en-US"/>
           </a:p>
@@ -694,7 +699,7 @@
           <a:p>
             <a:fld id="{B40FAA0D-FEED-4950-B1C4-DEC1AD7E6420}" type="datetimeFigureOut">
               <a:rPr lang="en-US" smtClean="0"/>
-              <a:t>5/12/2026</a:t>
+              <a:t>5/13/2026</a:t>
             </a:fld>
             <a:endParaRPr lang="en-US"/>
           </a:p>
@@ -892,7 +897,7 @@
           <a:p>
             <a:fld id="{B40FAA0D-FEED-4950-B1C4-DEC1AD7E6420}" type="datetimeFigureOut">
               <a:rPr lang="en-US" smtClean="0"/>
-              <a:t>5/12/2026</a:t>
+              <a:t>5/13/2026</a:t>
             </a:fld>
             <a:endParaRPr lang="en-US"/>
           </a:p>
@@ -1100,7 +1105,7 @@
           <a:p>
             <a:fld id="{B40FAA0D-FEED-4950-B1C4-DEC1AD7E6420}" type="datetimeFigureOut">
               <a:rPr lang="en-US" smtClean="0"/>
-              <a:t>5/12/2026</a:t>
+              <a:t>5/13/2026</a:t>
             </a:fld>
             <a:endParaRPr lang="en-US"/>
           </a:p>
@@ -1298,7 +1303,7 @@
           <a:p>
             <a:fld id="{B40FAA0D-FEED-4950-B1C4-DEC1AD7E6420}" type="datetimeFigureOut">
               <a:rPr lang="en-US" smtClean="0"/>
-              <a:t>5/12/2026</a:t>
+              <a:t>5/13/2026</a:t>
             </a:fld>
             <a:endParaRPr lang="en-US"/>
           </a:p>
@@ -1573,7 +1578,7 @@
           <a:p>
             <a:fld id="{B40FAA0D-FEED-4950-B1C4-DEC1AD7E6420}" type="datetimeFigureOut">
               <a:rPr lang="en-US" smtClean="0"/>
-              <a:t>5/12/2026</a:t>
+              <a:t>5/13/2026</a:t>
             </a:fld>
             <a:endParaRPr lang="en-US"/>
           </a:p>
@@ -1838,7 +1843,7 @@
           <a:p>
             <a:fld id="{B40FAA0D-FEED-4950-B1C4-DEC1AD7E6420}" type="datetimeFigureOut">
               <a:rPr lang="en-US" smtClean="0"/>
-              <a:t>5/12/2026</a:t>
+              <a:t>5/13/2026</a:t>
             </a:fld>
             <a:endParaRPr lang="en-US"/>
           </a:p>
@@ -2250,7 +2255,7 @@
           <a:p>
             <a:fld id="{B40FAA0D-FEED-4950-B1C4-DEC1AD7E6420}" type="datetimeFigureOut">
               <a:rPr lang="en-US" smtClean="0"/>
-              <a:t>5/12/2026</a:t>
+              <a:t>5/13/2026</a:t>
             </a:fld>
             <a:endParaRPr lang="en-US"/>
           </a:p>
@@ -2391,7 +2396,7 @@
           <a:p>
             <a:fld id="{B40FAA0D-FEED-4950-B1C4-DEC1AD7E6420}" type="datetimeFigureOut">
               <a:rPr lang="en-US" smtClean="0"/>
-              <a:t>5/12/2026</a:t>
+              <a:t>5/13/2026</a:t>
             </a:fld>
             <a:endParaRPr lang="en-US"/>
           </a:p>
@@ -2504,7 +2509,7 @@
           <a:p>
             <a:fld id="{B40FAA0D-FEED-4950-B1C4-DEC1AD7E6420}" type="datetimeFigureOut">
               <a:rPr lang="en-US" smtClean="0"/>
-              <a:t>5/12/2026</a:t>
+              <a:t>5/13/2026</a:t>
             </a:fld>
             <a:endParaRPr lang="en-US"/>
           </a:p>
@@ -2815,7 +2820,7 @@
           <a:p>
             <a:fld id="{B40FAA0D-FEED-4950-B1C4-DEC1AD7E6420}" type="datetimeFigureOut">
               <a:rPr lang="en-US" smtClean="0"/>
-              <a:t>5/12/2026</a:t>
+              <a:t>5/13/2026</a:t>
             </a:fld>
             <a:endParaRPr lang="en-US"/>
           </a:p>
@@ -3103,7 +3108,7 @@
           <a:p>
             <a:fld id="{B40FAA0D-FEED-4950-B1C4-DEC1AD7E6420}" type="datetimeFigureOut">
               <a:rPr lang="en-US" smtClean="0"/>
-              <a:t>5/12/2026</a:t>
+              <a:t>5/13/2026</a:t>
             </a:fld>
             <a:endParaRPr lang="en-US"/>
           </a:p>
@@ -3344,7 +3349,7 @@
           <a:p>
             <a:fld id="{B40FAA0D-FEED-4950-B1C4-DEC1AD7E6420}" type="datetimeFigureOut">
               <a:rPr lang="en-US" smtClean="0"/>
-              <a:t>5/12/2026</a:t>
+              <a:t>5/13/2026</a:t>
             </a:fld>
             <a:endParaRPr lang="en-US"/>
           </a:p>
@@ -4149,7 +4154,7 @@
           <a:p>
             <a:r>
               <a:rPr lang="en-US" sz="2000" dirty="0"/>
-              <a:t>Target and Chaser spacecraft are both in circular GEO orbits with 0.001 deg inclination</a:t>
+              <a:t>Target and Chaser spacecraft are both in circular GEO orbits with ~0 deg inclination</a:t>
             </a:r>
           </a:p>
           <a:p>
@@ -4167,7 +4172,7 @@
           <a:p>
             <a:r>
               <a:rPr lang="en-US" sz="2000" dirty="0"/>
-              <a:t>Target is prograde of chaser</a:t>
+              <a:t>Target is prograde of chaser initially</a:t>
             </a:r>
           </a:p>
         </p:txBody>
@@ -4298,22 +4303,14 @@
             <a:pPr lvl="1"/>
             <a:r>
               <a:rPr lang="en-US" dirty="0"/>
-              <a:t>Semimajor axis</a:t>
-            </a:r>
-            <a:r>
-              <a:rPr lang="en-US"/>
-              <a:t>: 42,164.15 </a:t>
-            </a:r>
+              <a:t>Semimajor axis: 42,164.15 km</a:t>
+            </a:r>
+          </a:p>
+          <a:p>
+            <a:pPr lvl="1"/>
             <a:r>
               <a:rPr lang="en-US" dirty="0"/>
-              <a:t>km</a:t>
-            </a:r>
-          </a:p>
-          <a:p>
-            <a:pPr lvl="1"/>
-            <a:r>
-              <a:rPr lang="en-US" dirty="0"/>
-              <a:t>Eccentricity: 0.00001</a:t>
+              <a:t>Eccentricity: 0.0</a:t>
             </a:r>
           </a:p>
           <a:p>
@@ -4342,6 +4339,12 @@
             <a:r>
               <a:rPr lang="en-US" dirty="0"/>
               <a:t>True anomaly: 0.0</a:t>
+            </a:r>
+          </a:p>
+          <a:p>
+            <a:r>
+              <a:rPr lang="en-US" dirty="0"/>
+              <a:t>Assuming we need 15 minutes to prepare for burn maneuvers</a:t>
             </a:r>
           </a:p>
           <a:p>
@@ -4524,8 +4527,8 @@
           </a:p>
         </p:txBody>
       </p:sp>
-      <mc:AlternateContent xmlns:mc="http://schemas.openxmlformats.org/markup-compatibility/2006">
-        <mc:Choice xmlns:a14="http://schemas.microsoft.com/office/drawing/2010/main" Requires="a14">
+      <mc:AlternateContent xmlns:mc="http://schemas.openxmlformats.org/markup-compatibility/2006" xmlns:a14="http://schemas.microsoft.com/office/drawing/2010/main">
+        <mc:Choice Requires="a14">
           <p:sp>
             <p:nvSpPr>
               <p:cNvPr id="7" name="TextBox 6">
@@ -4554,6 +4557,7 @@
               </a:bodyPr>
               <a:lstStyle/>
               <a:p>
+                <a:pPr/>
                 <a14:m>
                   <m:oMathPara xmlns:m="http://schemas.openxmlformats.org/officeDocument/2006/math">
                     <m:oMathParaPr>
@@ -4742,7 +4746,7 @@
             </p:txBody>
           </p:sp>
         </mc:Choice>
-        <mc:Fallback>
+        <mc:Fallback xmlns="">
           <p:sp>
             <p:nvSpPr>
               <p:cNvPr id="7" name="TextBox 6">
@@ -4981,8 +4985,8 @@
           </a:p>
         </p:txBody>
       </p:sp>
-      <mc:AlternateContent xmlns:mc="http://schemas.openxmlformats.org/markup-compatibility/2006">
-        <mc:Choice xmlns:a14="http://schemas.microsoft.com/office/drawing/2010/main" Requires="a14">
+      <mc:AlternateContent xmlns:mc="http://schemas.openxmlformats.org/markup-compatibility/2006" xmlns:a14="http://schemas.microsoft.com/office/drawing/2010/main">
+        <mc:Choice Requires="a14">
           <p:sp>
             <p:nvSpPr>
               <p:cNvPr id="17" name="TextBox 16">
@@ -5011,6 +5015,7 @@
               </a:bodyPr>
               <a:lstStyle/>
               <a:p>
+                <a:pPr/>
                 <a14:m>
                   <m:oMathPara xmlns:m="http://schemas.openxmlformats.org/officeDocument/2006/math">
                     <m:oMathParaPr>
@@ -5057,14 +5062,7 @@
                           <a:latin typeface="Cambria Math" panose="02040503050406030204" pitchFamily="18" charset="0"/>
                           <a:ea typeface="Cambria Math" panose="02040503050406030204" pitchFamily="18" charset="0"/>
                         </a:rPr>
-                        <m:t>=</m:t>
-                      </m:r>
-                      <m:r>
-                        <a:rPr lang="en-US" b="0" i="1" smtClean="0">
-                          <a:latin typeface="Cambria Math" panose="02040503050406030204" pitchFamily="18" charset="0"/>
-                          <a:ea typeface="Cambria Math" panose="02040503050406030204" pitchFamily="18" charset="0"/>
-                        </a:rPr>
-                        <m:t>2</m:t>
+                        <m:t>=2</m:t>
                       </m:r>
                       <m:func>
                         <m:funcPr>
@@ -5183,21 +5181,7 @@
                                       <a:latin typeface="Cambria Math" panose="02040503050406030204" pitchFamily="18" charset="0"/>
                                       <a:ea typeface="Cambria Math" panose="02040503050406030204" pitchFamily="18" charset="0"/>
                                     </a:rPr>
-                                    <m:t>42164</m:t>
-                                  </m:r>
-                                  <m:r>
-                                    <a:rPr lang="en-US" b="0" i="1" smtClean="0">
-                                      <a:latin typeface="Cambria Math" panose="02040503050406030204" pitchFamily="18" charset="0"/>
-                                      <a:ea typeface="Cambria Math" panose="02040503050406030204" pitchFamily="18" charset="0"/>
-                                    </a:rPr>
-                                    <m:t>.15</m:t>
-                                  </m:r>
-                                  <m:r>
-                                    <a:rPr lang="en-US" b="0" i="1" smtClean="0">
-                                      <a:latin typeface="Cambria Math" panose="02040503050406030204" pitchFamily="18" charset="0"/>
-                                      <a:ea typeface="Cambria Math" panose="02040503050406030204" pitchFamily="18" charset="0"/>
-                                    </a:rPr>
-                                    <m:t> </m:t>
+                                    <m:t>42164.15 </m:t>
                                   </m:r>
                                   <m:r>
                                     <a:rPr lang="en-US" b="0" i="1" smtClean="0">
@@ -5220,7 +5204,7 @@
             </p:txBody>
           </p:sp>
         </mc:Choice>
-        <mc:Fallback>
+        <mc:Fallback xmlns="">
           <p:sp>
             <p:nvSpPr>
               <p:cNvPr id="17" name="TextBox 16">

</xml_diff>